<commit_message>
HackNowa links live: README + slide 10 wired to hacknowa deploys, deck regenerated
</commit_message>
<xml_diff>
--- a/SWARN-CONTROL.AI.pptx
+++ b/SWARN-CONTROL.AI.pptx
@@ -3134,7 +3134,7 @@
                   <a:srgbClr val="F5A30B"/>
                 </a:solidFill>
               </a:rPr>
-              <a:t>SANGYAN 2026 · INVESTOR RESILIENCE HACKATHON · TRACK A + E</a:t>
+              <a:t>HACKNOWA GLOBAL HACKATHON 2026 · DIGITAL SAFETY &amp; CYBERSECURITY</a:t>
             </a:r>
           </a:p>
         </p:txBody>
@@ -3466,7 +3466,7 @@
                   <a:srgbClr val="22D3EE"/>
                 </a:solidFill>
               </a:rPr>
-              <a:t>▸  Live Demo: https://swarna-control-ai.vercel.app  ·  Backend: https://swarn-control-backend.onrender.com  ·  GitHub: github.com/Aryansneha1845/SWARNA-CONTROL.AI</a:t>
+              <a:t>▸  Live Demo: https://swarn-control-hacknowa.vercel.app  ·  Backend: https://swarn-control-hacknowa.onrender.com  ·  GitHub: github.com/Aryansneha1845/-SWARN-CONTROL-HACKNOWA</a:t>
             </a:r>
           </a:p>
           <a:p>

</xml_diff>